<commit_message>
refactor(kpis): reemplazar KPI 5 de auditoria por KPI 100% de negocio (Participacion y Dependencia por Socio Comercial) y actualizar entregables docx y pptx
</commit_message>
<xml_diff>
--- a/PRESENTACION_DEFENSA_ETL_ADUANAS_CHILE.pptx
+++ b/PRESENTACION_DEFENSA_ETL_ADUANAS_CHILE.pptx
@@ -1268,7 +1268,7 @@
           </a:p>
           <a:p>
             <a:r>
-              <a:t>En el Data Mart calculamos los 5 indicadores en SQL. Los resultados muestran que San Antonio concentra casi el 36% del tonelaje nacional, lo que enciende una alerta operativa ante marejadas o paros portuarios. Además, el costo logístico marítimo promedia un saludable 6,8% sobre el valor CIF, cumpliendo con creces la meta del 10%.</a:t>
+              <a:t>En el Data Mart calculamos 5 indicadores 100% orientados al negocio aduanero y logístico nacional. Monitoreamos balanza comercial por puerto, costos logísticos, concentración portuaria en San Antonio, densidad de valor económico por tonelada y el índice de dependencia por socio comercial para alertar sobreexposiciones económicas.</a:t>
             </a:r>
           </a:p>
         </p:txBody>
@@ -8546,7 +8546,7 @@
               </a:defRPr>
             </a:pPr>
             <a:r>
-              <a:t>Indicadores Estratégicos y de Calidad</a:t>
+              <a:t>Indicadores Estratégicos y de Mercado</a:t>
             </a:r>
           </a:p>
           <a:p>
@@ -8578,23 +8578,23 @@
               </a:defRPr>
             </a:pPr>
             <a:r>
-              <a:t>• KPI 5 (Calidad ETL y Auditoría): Tasa de retención del 100% sobre registros válidos, porcentaje de nulos crudos controlado (2,4%) y tiempo de ejecución &lt; 45 seg.</a:t>
-            </a:r>
-          </a:p>
-          <a:p>
-            <a:pPr>
-              <a:spcAft>
-                <a:spcPts val="400"/>
-              </a:spcAft>
-              <a:defRPr sz="1000">
-                <a:solidFill>
-                  <a:srgbClr val="1E293B"/>
-                </a:solidFill>
-                <a:latin typeface="Arial"/>
-              </a:defRPr>
-            </a:pPr>
-            <a:r>
-              <a:t>• Visualización Complementaria: Dashboard HTML interactivo con gráficos dinámicos en Chart.js.</a:t>
+              <a:t>• KPI 5 (Dependencia por Socio Comercial): Grado de concentración de mercado exterior (FOB + CIF). Monitorea el umbral de alerta del 35% para mitigar riesgos geopolíticos.</a:t>
+            </a:r>
+          </a:p>
+          <a:p>
+            <a:pPr>
+              <a:spcAft>
+                <a:spcPts val="400"/>
+              </a:spcAft>
+              <a:defRPr sz="1000">
+                <a:solidFill>
+                  <a:srgbClr val="1E293B"/>
+                </a:solidFill>
+                <a:latin typeface="Arial"/>
+              </a:defRPr>
+            </a:pPr>
+            <a:r>
+              <a:t>• Enfoque 100% de Negocio: Todos los KPIs responden a decisiones aduaneras y logísticas reales; las métricas de pipeline residen en public.etl_audit.</a:t>
             </a:r>
           </a:p>
         </p:txBody>

</xml_diff>